<commit_message>
Retire "entertainment literacy"; rename Tier 1 to Everyday play
Rewrites every use of the retired phrase in source files sentence by
sentence. Tier 1 is now named Everyday play wherever the tier is named.
Operator, regulator, and industry surfaces use the positioning line
"One open standard for responsible gambling"; player-facing copy
describes what the content does instead.

Regenerates api/ctas.json and collateral/render/playbook-brand-deck.pptx.
Frozen model-comparison records and image-API output copies are left
unchanged.
</commit_message>
<xml_diff>
--- a/collateral/render/playbook-brand-deck.pptx
+++ b/collateral/render/playbook-brand-deck.pptx
@@ -2045,7 +2045,7 @@
                 <a:ea typeface="Source Sans 3" pitchFamily="34" charset="-122"/>
                 <a:cs typeface="Source Sans 3" pitchFamily="34" charset="-120"/>
               </a:rPr>
-              <a:t>Gambling Entertainment Literacy — A White-Label Brand System</a:t>
+              <a:t>One open standard for responsible gambling</a:t>
             </a:r>
             <a:endParaRPr lang="en-US" sz="1600" dirty="0"/>
           </a:p>
@@ -12670,7 +12670,7 @@
                 <a:ea typeface="Inter" pitchFamily="34" charset="-122"/>
                 <a:cs typeface="Inter" pitchFamily="34" charset="-120"/>
               </a:rPr>
-              <a:t>Tier 1 — 95%  Entertainment Literacy</a:t>
+              <a:t>Tier 1 — 95%  Everyday Play</a:t>
             </a:r>
             <a:endParaRPr lang="en-US" sz="1500" dirty="0"/>
           </a:p>

</xml_diff>